<commit_message>
Add Arabic hardware wiring picture; use it in the report and presentation
Clear wiring diagram of the real ESP32 DevKit V1 (30-pin) with every
module, colour-coded wires, 3.3 V / GND rails, the 100 ohm buzzer resistor
and a legend.

Co-Authored-By: Claude Opus 5.5 <noreply@anthropic.com>
Claude-Session: https://claude.ai/code/session_01LUEXdLPnpgGnWTyNRXft8r
</commit_message>
<xml_diff>
--- a/rayy-mysql/docs/final-submission/العرض النهائي - ري.pptx
+++ b/rayy-mysql/docs/final-submission/العرض النهائي - ري.pptx
@@ -125,12 +125,12 @@
   <p:extLst>
     <p:ext uri="{521415D9-36F7-43E2-AB2F-B90AF26B5E84}">
       <p14:sectionLst xmlns:p14="http://schemas.microsoft.com/office/powerpoint/2010/main">
-        <p14:section name="البداية" id="{85023236-76c8-26ec-17f1-2cc49cab47d0}">
+        <p14:section name="البداية" id="{f0a44872-f100-9a98-a012-a6cdeedf5fa5}">
           <p14:sldIdLst>
             <p14:sldId id="256"/>
           </p14:sldIdLst>
         </p14:section>
-        <p14:section name="المشكلة والحل" id="{0aa578ab-1240-333f-ca5a-7a12669c7e53}">
+        <p14:section name="المشكلة والحل" id="{ef5cd027-0f48-5769-5f15-b71e2c14d9e1}">
           <p14:sldIdLst>
             <p14:sldId id="257"/>
             <p14:sldId id="258"/>
@@ -138,7 +138,7 @@
             <p14:sldId id="260"/>
           </p14:sldIdLst>
         </p14:section>
-        <p14:section name="تصميم النظام" id="{948b2a25-da79-710b-9cc2-9158d609bbd5}">
+        <p14:section name="تصميم النظام" id="{8e182181-f8b3-9954-2ef8-fbb484507fbe}">
           <p14:sldIdLst>
             <p14:sldId id="261"/>
             <p14:sldId id="262"/>
@@ -148,7 +148,7 @@
             <p14:sldId id="266"/>
           </p14:sldIdLst>
         </p14:section>
-        <p14:section name="النتائج" id="{2884cc6c-2859-bb69-731c-133291b971a2}">
+        <p14:section name="النتائج" id="{a7e14cf8-63c5-88cc-ce1e-a0e1acb62680}">
           <p14:sldIdLst>
             <p14:sldId id="267"/>
             <p14:sldId id="268"/>
@@ -157,7 +157,7 @@
             <p14:sldId id="271"/>
           </p14:sldIdLst>
         </p14:section>
-        <p14:section name="الختام" id="{e3aead7a-ebb8-d309-bb71-9076c5c424a9}">
+        <p14:section name="الختام" id="{5229398e-719f-3254-a266-921d660f8c51}">
           <p14:sldIdLst>
             <p14:sldId id="272"/>
             <p14:sldId id="273"/>
@@ -11536,8 +11536,8 @@
         </p:blipFill>
         <p:spPr>
           <a:xfrm>
-            <a:off x="457200" y="1771122"/>
-            <a:ext cx="6766560" cy="3955835"/>
+            <a:off x="457200" y="1380744"/>
+            <a:ext cx="6766560" cy="4736592"/>
           </a:xfrm>
           <a:prstGeom prst="rect">
             <a:avLst/>

</xml_diff>